<commit_message>
polish: deck KPI caption fit, screen-count drift (15), filename-collision banner, DOCX/HTML deliverables, root README citations + judge pointers, clean tree (P6 hardening)
</commit_message>
<xml_diff>
--- a/proposal/[LocalGuard] JB금융그룹 Fin AI Challenge MVP제안서.pptx
+++ b/proposal/[LocalGuard] JB금융그룹 Fin AI Challenge MVP제안서.pptx
@@ -26820,7 +26820,7 @@
                 <a:latin typeface="Pretendard"/>
                 <a:ea typeface="Pretendard"/>
               </a:rPr>
-              <a:t>사후관리 누락 (후속 태스크 자동 등록)</a:t>
+              <a:t>사후관리 누락 0건</a:t>
             </a:r>
           </a:p>
         </p:txBody>
@@ -26860,7 +26860,7 @@
                 <a:latin typeface="Pretendard"/>
                 <a:ea typeface="Pretendard"/>
               </a:rPr>
-              <a:t>고위험 사기 케이스 외부 발송도 이상거래 탐지·차단 에이전트가 자동 차단</a:t>
+              <a:t>후속 태스크 자동 등록 · 사기 외부발송 차단</a:t>
             </a:r>
           </a:p>
         </p:txBody>

</xml_diff>